<commit_message>
Update MCP Community Connect presentation file
</commit_message>
<xml_diff>
--- a/docs/Presentation/MCP_Community_Connect_HoL_MCP.pptx
+++ b/docs/Presentation/MCP_Community_Connect_HoL_MCP.pptx
@@ -5,7 +5,7 @@
     <p:sldMasterId id="2147483648" r:id="rId1"/>
   </p:sldMasterIdLst>
   <p:notesMasterIdLst>
-    <p:notesMasterId r:id="rId9"/>
+    <p:notesMasterId r:id="rId11"/>
   </p:notesMasterIdLst>
   <p:sldIdLst>
     <p:sldId id="256" r:id="rId2"/>
@@ -13,8 +13,10 @@
     <p:sldId id="261" r:id="rId4"/>
     <p:sldId id="263" r:id="rId5"/>
     <p:sldId id="264" r:id="rId6"/>
-    <p:sldId id="265" r:id="rId7"/>
-    <p:sldId id="267" r:id="rId8"/>
+    <p:sldId id="268" r:id="rId7"/>
+    <p:sldId id="269" r:id="rId8"/>
+    <p:sldId id="265" r:id="rId9"/>
+    <p:sldId id="267" r:id="rId10"/>
   </p:sldIdLst>
   <p:sldSz cx="12192000" cy="6858000"/>
   <p:notesSz cx="6858000" cy="12192000"/>
@@ -143,7 +145,7 @@
     </p:spTree>
     <p:extLst>
       <p:ext uri="{BB962C8B-B14F-4D97-AF65-F5344CB8AC3E}">
-        <p14:creationId xmlns:p14="http://schemas.microsoft.com/office/powerpoint/2010/main" val="3778991677"/>
+        <p14:creationId xmlns:p14="http://schemas.microsoft.com/office/powerpoint/2010/main" val="431133954"/>
       </p:ext>
     </p:extLst>
   </p:cSld>
@@ -682,24 +684,12 @@
       </p:grpSpPr>
       <p:sp>
         <p:nvSpPr>
-          <p:cNvPr id="2" name="Slide Image Placeholder 1"/>
-          <p:cNvSpPr>
-            <a:spLocks noGrp="1" noRot="1" noChangeAspect="1"/>
-          </p:cNvSpPr>
-          <p:nvPr>
-            <p:ph type="sldImg"/>
-          </p:nvPr>
-        </p:nvSpPr>
-        <p:spPr/>
-      </p:sp>
-      <p:sp>
-        <p:nvSpPr>
-          <p:cNvPr id="3" name="Notes Placeholder 2"/>
+          <p:cNvPr id="99" name="Notes"/>
           <p:cNvSpPr>
             <a:spLocks noGrp="1"/>
           </p:cNvSpPr>
           <p:nvPr>
-            <p:ph type="body" idx="1"/>
+            <p:ph type="body" idx="13"/>
           </p:nvPr>
         </p:nvSpPr>
         <p:spPr/>
@@ -707,39 +697,106 @@
           <a:bodyPr/>
           <a:lstStyle/>
           <a:p>
-            <a:endParaRPr lang="en-US" dirty="0"/>
-          </a:p>
-        </p:txBody>
-      </p:sp>
-      <p:sp>
-        <p:nvSpPr>
-          <p:cNvPr id="4" name="Slide Number Placeholder 3"/>
-          <p:cNvSpPr>
-            <a:spLocks noGrp="1"/>
-          </p:cNvSpPr>
-          <p:nvPr>
-            <p:ph type="sldNum" sz="quarter" idx="10"/>
-          </p:nvPr>
-        </p:nvSpPr>
-        <p:spPr/>
-        <p:txBody>
-          <a:bodyPr/>
-          <a:lstStyle/>
-          <a:p>
-            <a:fld id="{F7021451-1387-4CA6-816F-3879F97B5CBC}" type="slidenum">
-              <a:rPr lang="en-US"/>
-              <a:t>6</a:t>
-            </a:fld>
-            <a:endParaRPr lang="en-US"/>
+            <a:r>
+              <a:t>Bring your own VM setup guide.</a:t>
+            </a:r>
+          </a:p>
+          <a:p>
+            <a:r>
+              <a:t>Mac: use UTM's official Windows guide. Obtain a licensed Windows 11 ISO for the host architecture. In UTM choose +, Virtualize, Windows, select the ISO and install drivers / SPICE tools. Allocate resources appropriate to the host and install Windows. The repository evidence does not establish UTM/Windows ARM compatibility. Treat this route as unverified until the workshop acceptance checks pass on that specific machine.</a:t>
+            </a:r>
+          </a:p>
+          <a:p>
+            <a:r>
+              <a:t>Windows: use a Hyper-V-capable Windows edition and hardware with virtualization enabled. Enable Hyper-V, restart if requested, and open Hyper-V Manager. Select New &gt; Virtual Machine, Generation 2. Configure RAM, virtual disk, and a connected virtual switch. Attach a Windows 11 ISO. Before booting, enable Secure Boot and Trusted Platform Module in VM Security settings, then install Windows. Use a valid Windows license.</a:t>
+            </a:r>
+          </a:p>
+          <a:p>
+            <a:r>
+              <a:t>For either guest, prepare the image while online. The repository runbook requires supported 64-bit Windows, Python 3.11 or newer with the py launcher, VS Code with Python extension, and the repository in an accessible short path. Git is useful for cloning or updating the repository.</a:t>
+            </a:r>
+          </a:p>
+          <a:p>
+            <a:r>
+              <a:t>Example acquisition command: git clone https://github.com/GlobalAICommunity/mcp-fl-workshop.git</a:t>
+            </a:r>
+          </a:p>
+          <a:p>
+            <a:r>
+              <a:t>Then: cd mcp-fl-workshop</a:t>
+            </a:r>
+          </a:p>
+          <a:p>
+            <a:r>
+              <a:t>Use docs/vm-image-runbook.md for the current dependency and model-cache setup. Run remaining setup as the same non-administrator account used during the workshop because the cache is user-scoped.</a:t>
+            </a:r>
+          </a:p>
+          <a:p>
+            <a:r>
+              <a:t>Repository troubleshooting documents environment creation using py -3.11 -m venv .venv and .\.venv\Scripts\python -m pip install -r requirements-lock.txt. Follow the current runbook for the full process, including model caching.</a:t>
+            </a:r>
+          </a:p>
+          <a:p>
+            <a:r>
+              <a:t>Acceptance: disable networking and run .\workshop.ps1 check from the repository root. All checks must pass, including loading the cached model and producing a get_weather tool request. An OS installation alone is not a prepared workshop image. Test performance on representative hardware.</a:t>
+            </a:r>
+          </a:p>
+          <a:p>
+            <a:r>
+              <a:t>[Sources]</a:t>
+            </a:r>
+          </a:p>
+          <a:p>
+            <a:r>
+              <a:t>https://</a:t>
+            </a:r>
+            <a:r>
+              <a:rPr lang="en-GB"/>
+              <a:t>mac.getutm.app/</a:t>
+            </a:r>
+          </a:p>
+          <a:p>
+            <a:r>
+              <a:rPr lang="en-GB"/>
+              <a:t>https://</a:t>
+            </a:r>
+            <a:r>
+              <a:t>github.com/GlobalAICommunity/mcp-fl-workshop</a:t>
+            </a:r>
+          </a:p>
+          <a:p>
+            <a:r>
+              <a:t>https://github.com/GlobalAICommunity/mcp-fl-workshop/blob/main/docs/vm-image-runbook.md</a:t>
+            </a:r>
+          </a:p>
+          <a:p>
+            <a:r>
+              <a:t>https://github.com/GlobalAICommunity/mcp-fl-workshop/blob/main/docs/troubleshooting.md</a:t>
+            </a:r>
+          </a:p>
+          <a:p>
+            <a:r>
+              <a:t>https://docs.getutm.app/guides/windows/</a:t>
+            </a:r>
+          </a:p>
+          <a:p>
+            <a:r>
+              <a:t>https://learn.microsoft.com/en-us/windows-server/virtualization/hyper-v/get-started/create-a-virtual-machine-in-hyper-v</a:t>
+            </a:r>
+          </a:p>
+          <a:p>
+            <a:r>
+              <a:t>https://learn.microsoft.com/en-us/windows-server/virtualization/hyper-v/generation-2-virtual-machine-security-features</a:t>
+            </a:r>
+          </a:p>
+          <a:p>
+            <a:r>
+              <a:t>[/Sources]</a:t>
+            </a:r>
           </a:p>
         </p:txBody>
       </p:sp>
     </p:spTree>
-    <p:extLst>
-      <p:ext uri="{BB962C8B-B14F-4D97-AF65-F5344CB8AC3E}">
-        <p14:creationId xmlns:p14="http://schemas.microsoft.com/office/powerpoint/2010/main" val="1024086991"/>
-      </p:ext>
-    </p:extLst>
   </p:cSld>
   <p:clrMapOvr>
     <a:masterClrMapping/>
@@ -766,6 +823,87 @@
       </p:grpSpPr>
       <p:sp>
         <p:nvSpPr>
+          <p:cNvPr id="99" name="Notes"/>
+          <p:cNvSpPr>
+            <a:spLocks noGrp="1"/>
+          </p:cNvSpPr>
+          <p:nvPr>
+            <p:ph type="body" idx="13"/>
+          </p:nvPr>
+        </p:nvSpPr>
+        <p:spPr/>
+        <p:txBody>
+          <a:bodyPr/>
+          <a:lstStyle/>
+          <a:p>
+            <a:r>
+              <a:t>Open the workshop repository in GitHub and use Code, Codespaces, Create codespace on main. Wait for the browser editor to open. The repository is available in the codespace, so open docs/codespaces/README.md and follow its current setup and run instructions.</a:t>
+            </a:r>
+          </a:p>
+          <a:p>
+            <a:r>
+              <a:t>The presenter supplied the Codespaces guide address. Its page content could not be retrieved during slide preparation, so this slide provides the launch workflow and guide location without asserting specific dependencies, model runtime, ports, or commands.</a:t>
+            </a:r>
+          </a:p>
+          <a:p>
+            <a:r>
+              <a:t>[Sources]</a:t>
+            </a:r>
+          </a:p>
+          <a:p>
+            <a:r>
+              <a:t>User-supplied guide location: https://github.com/GlobalAICommunity/mcp-fl-workshop/blob/main/docs/codespaces/README.md</a:t>
+            </a:r>
+          </a:p>
+          <a:p>
+            <a:r>
+              <a:t>Repository: https://github.com/GlobalAICommunity/mcp-fl-workshop</a:t>
+            </a:r>
+          </a:p>
+          <a:p>
+            <a:r>
+              <a:t>Codespaces launch workflow: https://docs.github.com/en/codespaces/developing-in-a-codespace/creating-a-codespace-for-a-repository</a:t>
+            </a:r>
+          </a:p>
+          <a:p>
+            <a:r>
+              <a:t>https://docs.github.com/codespaces/quickstart</a:t>
+            </a:r>
+          </a:p>
+          <a:p>
+            <a:r>
+              <a:t>[/Sources]</a:t>
+            </a:r>
+          </a:p>
+        </p:txBody>
+      </p:sp>
+    </p:spTree>
+  </p:cSld>
+  <p:clrMapOvr>
+    <a:masterClrMapping/>
+  </p:clrMapOvr>
+</p:notes>
+</file>
+
+<file path=ppt/notesSlides/notesSlide8.xml><?xml version="1.0" encoding="utf-8"?>
+<p:notes xmlns:a="http://schemas.openxmlformats.org/drawingml/2006/main" xmlns:r="http://schemas.openxmlformats.org/officeDocument/2006/relationships" xmlns:p="http://schemas.openxmlformats.org/presentationml/2006/main">
+  <p:cSld>
+    <p:spTree>
+      <p:nvGrpSpPr>
+        <p:cNvPr id="1" name=""/>
+        <p:cNvGrpSpPr/>
+        <p:nvPr/>
+      </p:nvGrpSpPr>
+      <p:grpSpPr>
+        <a:xfrm>
+          <a:off x="0" y="0"/>
+          <a:ext cx="0" cy="0"/>
+          <a:chOff x="0" y="0"/>
+          <a:chExt cx="0" cy="0"/>
+        </a:xfrm>
+      </p:grpSpPr>
+      <p:sp>
+        <p:nvSpPr>
           <p:cNvPr id="2" name="Slide Image Placeholder 1"/>
           <p:cNvSpPr>
             <a:spLocks noGrp="1" noRot="1" noChangeAspect="1"/>
@@ -812,7 +950,91 @@
           <a:p>
             <a:fld id="{F7021451-1387-4CA6-816F-3879F97B5CBC}" type="slidenum">
               <a:rPr lang="en-US"/>
-              <a:t>7</a:t>
+              <a:t>8</a:t>
+            </a:fld>
+            <a:endParaRPr lang="en-US"/>
+          </a:p>
+        </p:txBody>
+      </p:sp>
+    </p:spTree>
+    <p:extLst>
+      <p:ext uri="{BB962C8B-B14F-4D97-AF65-F5344CB8AC3E}">
+        <p14:creationId xmlns:p14="http://schemas.microsoft.com/office/powerpoint/2010/main" val="1024086991"/>
+      </p:ext>
+    </p:extLst>
+  </p:cSld>
+  <p:clrMapOvr>
+    <a:masterClrMapping/>
+  </p:clrMapOvr>
+</p:notes>
+</file>
+
+<file path=ppt/notesSlides/notesSlide9.xml><?xml version="1.0" encoding="utf-8"?>
+<p:notes xmlns:a="http://schemas.openxmlformats.org/drawingml/2006/main" xmlns:r="http://schemas.openxmlformats.org/officeDocument/2006/relationships" xmlns:p="http://schemas.openxmlformats.org/presentationml/2006/main">
+  <p:cSld>
+    <p:spTree>
+      <p:nvGrpSpPr>
+        <p:cNvPr id="1" name=""/>
+        <p:cNvGrpSpPr/>
+        <p:nvPr/>
+      </p:nvGrpSpPr>
+      <p:grpSpPr>
+        <a:xfrm>
+          <a:off x="0" y="0"/>
+          <a:ext cx="0" cy="0"/>
+          <a:chOff x="0" y="0"/>
+          <a:chExt cx="0" cy="0"/>
+        </a:xfrm>
+      </p:grpSpPr>
+      <p:sp>
+        <p:nvSpPr>
+          <p:cNvPr id="2" name="Slide Image Placeholder 1"/>
+          <p:cNvSpPr>
+            <a:spLocks noGrp="1" noRot="1" noChangeAspect="1"/>
+          </p:cNvSpPr>
+          <p:nvPr>
+            <p:ph type="sldImg"/>
+          </p:nvPr>
+        </p:nvSpPr>
+        <p:spPr/>
+      </p:sp>
+      <p:sp>
+        <p:nvSpPr>
+          <p:cNvPr id="3" name="Notes Placeholder 2"/>
+          <p:cNvSpPr>
+            <a:spLocks noGrp="1"/>
+          </p:cNvSpPr>
+          <p:nvPr>
+            <p:ph type="body" idx="1"/>
+          </p:nvPr>
+        </p:nvSpPr>
+        <p:spPr/>
+        <p:txBody>
+          <a:bodyPr/>
+          <a:lstStyle/>
+          <a:p>
+            <a:endParaRPr lang="en-US" dirty="0"/>
+          </a:p>
+        </p:txBody>
+      </p:sp>
+      <p:sp>
+        <p:nvSpPr>
+          <p:cNvPr id="4" name="Slide Number Placeholder 3"/>
+          <p:cNvSpPr>
+            <a:spLocks noGrp="1"/>
+          </p:cNvSpPr>
+          <p:nvPr>
+            <p:ph type="sldNum" sz="quarter" idx="10"/>
+          </p:nvPr>
+        </p:nvSpPr>
+        <p:spPr/>
+        <p:txBody>
+          <a:bodyPr/>
+          <a:lstStyle/>
+          <a:p>
+            <a:fld id="{F7021451-1387-4CA6-816F-3879F97B5CBC}" type="slidenum">
+              <a:rPr lang="en-US"/>
+              <a:t>9</a:t>
             </a:fld>
             <a:endParaRPr lang="en-US"/>
           </a:p>
@@ -975,7 +1197,7 @@
               <a:buNone/>
             </a:pPr>
             <a:r>
-              <a:rPr lang="en-US" sz="750" b="1" kern="0" spc="140" dirty="0">
+              <a:rPr lang="en-US" sz="750" b="1" kern="0" spc="140">
                 <a:solidFill>
                   <a:srgbClr val="7ED9E4"/>
                 </a:solidFill>
@@ -985,7 +1207,7 @@
               </a:rPr>
               <a:t>MCP COMMUNITY CONNECT · BENGALURU</a:t>
             </a:r>
-            <a:endParaRPr lang="en-US" sz="750" dirty="0"/>
+            <a:endParaRPr lang="en-US" sz="750"/>
           </a:p>
         </p:txBody>
       </p:sp>
@@ -1014,7 +1236,7 @@
               <a:buNone/>
             </a:pPr>
             <a:r>
-              <a:rPr lang="en-US" sz="750" kern="0" spc="110" dirty="0">
+              <a:rPr lang="en-US" sz="750" kern="0" spc="110">
                 <a:solidFill>
                   <a:srgbClr val="AAB7D8"/>
                 </a:solidFill>
@@ -1024,7 +1246,7 @@
               </a:rPr>
               <a:t>26 SEPTEMBER 2026</a:t>
             </a:r>
-            <a:endParaRPr lang="en-US" sz="750" dirty="0"/>
+            <a:endParaRPr lang="en-US" sz="750"/>
           </a:p>
         </p:txBody>
       </p:sp>
@@ -1928,8 +2150,8 @@
         </p:blipFill>
         <p:spPr>
           <a:xfrm>
-            <a:off x="6858000" y="5230368"/>
-            <a:ext cx="4892040" cy="1143000"/>
+            <a:off x="7592862" y="5230368"/>
+            <a:ext cx="3422315" cy="1143000"/>
           </a:xfrm>
           <a:prstGeom prst="rect">
             <a:avLst/>
@@ -2309,11 +2531,8 @@
           <a:bodyPr wrap="square" lIns="0" tIns="0" rIns="0" bIns="0" rtlCol="0" anchor="ctr"/>
           <a:lstStyle/>
           <a:p>
-            <a:pPr marL="0" indent="0">
-              <a:buNone/>
-            </a:pPr>
-            <a:r>
-              <a:rPr lang="en-GB" sz="1400">
+            <a:r>
+              <a:rPr lang="en-GB" sz="1400" dirty="0">
                 <a:solidFill>
                   <a:srgbClr val="AAB7D8"/>
                 </a:solidFill>
@@ -2321,9 +2540,21 @@
                 <a:ea typeface="Carlito" pitchFamily="34" charset="-122"/>
                 <a:cs typeface="Carlito" pitchFamily="34" charset="-120"/>
               </a:rPr>
-              <a:t>A complete local path from protocol to browser.</a:t>
-            </a:r>
-            <a:endParaRPr lang="en-US" sz="1400" dirty="0"/>
+              <a:t>A complete local path from protocol to browser. </a:t>
+            </a:r>
+            <a:r>
+              <a:rPr lang="en-GB" b="1" dirty="0">
+                <a:solidFill>
+                  <a:schemeClr val="bg1"/>
+                </a:solidFill>
+              </a:rPr>
+              <a:t> Enter the Lab at https://aka.ms/AA13mn27 Training key:407E34CF994AEF76</a:t>
+            </a:r>
+            <a:endParaRPr lang="en-US" sz="1400" b="1" dirty="0">
+              <a:solidFill>
+                <a:schemeClr val="bg1"/>
+              </a:solidFill>
+            </a:endParaRPr>
           </a:p>
         </p:txBody>
       </p:sp>
@@ -5817,14 +6048,14 @@
       </p:sp>
       <p:sp>
         <p:nvSpPr>
-          <p:cNvPr id="12" name="Text 9"/>
-          <p:cNvSpPr/>
-          <p:nvPr/>
-        </p:nvSpPr>
-        <p:spPr>
-          <a:xfrm>
-            <a:off x="594360" y="502920"/>
-            <a:ext cx="5303520" cy="256032"/>
+          <p:cNvPr id="13" name="Text 10"/>
+          <p:cNvSpPr/>
+          <p:nvPr/>
+        </p:nvSpPr>
+        <p:spPr>
+          <a:xfrm>
+            <a:off x="594360" y="868680"/>
+            <a:ext cx="11597640" cy="658368"/>
           </a:xfrm>
           <a:prstGeom prst="rect">
             <a:avLst/>
@@ -5836,34 +6067,54 @@
           <a:bodyPr wrap="square" lIns="0" tIns="0" rIns="0" bIns="0" rtlCol="0" anchor="ctr"/>
           <a:lstStyle/>
           <a:p>
-            <a:pPr marL="0" indent="0">
-              <a:buNone/>
-            </a:pPr>
-            <a:r>
-              <a:rPr lang="en-US" sz="1100" b="1" kern="0" spc="200" dirty="0">
-                <a:solidFill>
-                  <a:srgbClr val="39C6D8"/>
+            <a:br>
+              <a:rPr lang="en-US" sz="2800" b="1" dirty="0">
+                <a:solidFill>
+                  <a:srgbClr val="F8FBFF"/>
                 </a:solidFill>
                 <a:latin typeface="Carlito" pitchFamily="34" charset="0"/>
                 <a:ea typeface="Carlito" pitchFamily="34" charset="-122"/>
                 <a:cs typeface="Carlito" pitchFamily="34" charset="-120"/>
               </a:rPr>
-              <a:t>DEMO</a:t>
-            </a:r>
-            <a:endParaRPr lang="en-US" sz="1100" dirty="0"/>
-          </a:p>
-        </p:txBody>
-      </p:sp>
-      <p:sp>
-        <p:nvSpPr>
-          <p:cNvPr id="13" name="Text 10"/>
-          <p:cNvSpPr/>
-          <p:nvPr/>
-        </p:nvSpPr>
-        <p:spPr>
-          <a:xfrm>
-            <a:off x="594360" y="868680"/>
-            <a:ext cx="9966960" cy="658368"/>
+            </a:br>
+            <a:r>
+              <a:rPr lang="en-GB" sz="2800" b="1" dirty="0">
+                <a:solidFill>
+                  <a:schemeClr val="bg1"/>
+                </a:solidFill>
+              </a:rPr>
+              <a:t>Enter the Lab at ***** go to </a:t>
+            </a:r>
+            <a:r>
+              <a:rPr lang="en-GB" sz="2800" b="1" dirty="0" err="1">
+                <a:solidFill>
+                  <a:schemeClr val="bg1"/>
+                </a:solidFill>
+              </a:rPr>
+              <a:t>MyTraining</a:t>
+            </a:r>
+            <a:r>
+              <a:rPr lang="en-GB" sz="2800" b="1" dirty="0">
+                <a:solidFill>
+                  <a:schemeClr val="bg1"/>
+                </a:solidFill>
+              </a:rPr>
+              <a:t> and add the following Training key:*******</a:t>
+            </a:r>
+            <a:endParaRPr lang="en-US" sz="2800" dirty="0"/>
+          </a:p>
+        </p:txBody>
+      </p:sp>
+      <p:sp>
+        <p:nvSpPr>
+          <p:cNvPr id="14" name="Text 11"/>
+          <p:cNvSpPr/>
+          <p:nvPr/>
+        </p:nvSpPr>
+        <p:spPr>
+          <a:xfrm>
+            <a:off x="594360" y="1986534"/>
+            <a:ext cx="9326880" cy="502920"/>
           </a:xfrm>
           <a:prstGeom prst="rect">
             <a:avLst/>
@@ -5879,53 +6130,14 @@
               <a:buNone/>
             </a:pPr>
             <a:r>
-              <a:rPr lang="en-US" sz="2800" b="1">
-                <a:solidFill>
-                  <a:srgbClr val="F8FBFF"/>
+              <a:rPr lang="en-GB" sz="1400" dirty="0">
+                <a:solidFill>
+                  <a:srgbClr val="AAB7D8"/>
                 </a:solidFill>
                 <a:latin typeface="Carlito" pitchFamily="34" charset="0"/>
                 <a:ea typeface="Carlito" pitchFamily="34" charset="-122"/>
                 <a:cs typeface="Carlito" pitchFamily="34" charset="-120"/>
               </a:rPr>
-              <a:t>Try the local agent</a:t>
-            </a:r>
-            <a:endParaRPr lang="en-US" sz="2800" dirty="0"/>
-          </a:p>
-        </p:txBody>
-      </p:sp>
-      <p:sp>
-        <p:nvSpPr>
-          <p:cNvPr id="14" name="Text 11"/>
-          <p:cNvSpPr/>
-          <p:nvPr/>
-        </p:nvSpPr>
-        <p:spPr>
-          <a:xfrm>
-            <a:off x="612648" y="1554480"/>
-            <a:ext cx="9326880" cy="502920"/>
-          </a:xfrm>
-          <a:prstGeom prst="rect">
-            <a:avLst/>
-          </a:prstGeom>
-          <a:noFill/>
-          <a:ln/>
-        </p:spPr>
-        <p:txBody>
-          <a:bodyPr wrap="square" lIns="0" tIns="0" rIns="0" bIns="0" rtlCol="0" anchor="ctr"/>
-          <a:lstStyle/>
-          <a:p>
-            <a:pPr marL="0" indent="0">
-              <a:buNone/>
-            </a:pPr>
-            <a:r>
-              <a:rPr lang="en-GB" sz="1400">
-                <a:solidFill>
-                  <a:srgbClr val="AAB7D8"/>
-                </a:solidFill>
-                <a:latin typeface="Carlito" pitchFamily="34" charset="0"/>
-                <a:ea typeface="Carlito" pitchFamily="34" charset="-122"/>
-                <a:cs typeface="Carlito" pitchFamily="34" charset="-120"/>
-              </a:rPr>
               <a:t>One model decision. One MCP call. Exact typed output.</a:t>
             </a:r>
             <a:endParaRPr lang="en-US" sz="1400" dirty="0"/>
@@ -5940,7 +6152,7 @@
         </p:nvSpPr>
         <p:spPr>
           <a:xfrm>
-            <a:off x="658368" y="2167128"/>
+            <a:off x="658368" y="2546604"/>
             <a:ext cx="7360920" cy="3703320"/>
           </a:xfrm>
           <a:prstGeom prst="roundRect">
@@ -5976,7 +6188,7 @@
         </p:nvSpPr>
         <p:spPr>
           <a:xfrm>
-            <a:off x="932688" y="2395728"/>
+            <a:off x="932688" y="2775204"/>
             <a:ext cx="109728" cy="109728"/>
           </a:xfrm>
           <a:prstGeom prst="ellipse">
@@ -6008,7 +6220,7 @@
         </p:nvSpPr>
         <p:spPr>
           <a:xfrm>
-            <a:off x="1115568" y="2395728"/>
+            <a:off x="1115568" y="2775204"/>
             <a:ext cx="109728" cy="109728"/>
           </a:xfrm>
           <a:prstGeom prst="ellipse">
@@ -6040,7 +6252,7 @@
         </p:nvSpPr>
         <p:spPr>
           <a:xfrm>
-            <a:off x="1298448" y="2395728"/>
+            <a:off x="1298448" y="2775204"/>
             <a:ext cx="109728" cy="109728"/>
           </a:xfrm>
           <a:prstGeom prst="ellipse">
@@ -6072,7 +6284,7 @@
         </p:nvSpPr>
         <p:spPr>
           <a:xfrm>
-            <a:off x="960120" y="2761488"/>
+            <a:off x="960120" y="3140964"/>
             <a:ext cx="6537960" cy="2423160"/>
           </a:xfrm>
           <a:prstGeom prst="rect">
@@ -6626,6 +6838,1700 @@
 </file>
 
 <file path=ppt/slides/slide6.xml><?xml version="1.0" encoding="utf-8"?>
+<p:sld xmlns:a="http://schemas.openxmlformats.org/drawingml/2006/main" xmlns:r="http://schemas.openxmlformats.org/officeDocument/2006/relationships" xmlns:p="http://schemas.openxmlformats.org/presentationml/2006/main">
+  <p:cSld>
+    <p:spTree>
+      <p:nvGrpSpPr>
+        <p:cNvPr id="1" name=""/>
+        <p:cNvGrpSpPr/>
+        <p:nvPr/>
+      </p:nvGrpSpPr>
+      <p:grpSpPr>
+        <a:xfrm>
+          <a:off x="0" y="0"/>
+          <a:ext cx="0" cy="0"/>
+          <a:chOff x="0" y="0"/>
+          <a:chExt cx="0" cy="0"/>
+        </a:xfrm>
+      </p:grpSpPr>
+      <p:sp>
+        <p:nvSpPr>
+          <p:cNvPr id="2" name="Shape 0"/>
+          <p:cNvSpPr/>
+          <p:nvPr/>
+        </p:nvSpPr>
+        <p:spPr>
+          <a:xfrm>
+            <a:off x="9966960" y="-1143000"/>
+            <a:ext cx="3383280" cy="3383280"/>
+          </a:xfrm>
+          <a:prstGeom prst="ellipse">
+            <a:avLst/>
+          </a:prstGeom>
+          <a:solidFill>
+            <a:srgbClr val="1E224E">
+              <a:alpha val="0"/>
+            </a:srgbClr>
+          </a:solidFill>
+          <a:ln w="16510">
+            <a:solidFill>
+              <a:srgbClr val="39C6D8">
+                <a:alpha val="38000"/>
+              </a:srgbClr>
+            </a:solidFill>
+            <a:prstDash val="solid"/>
+          </a:ln>
+        </p:spPr>
+        <p:txBody>
+          <a:bodyPr/>
+          <a:lstStyle/>
+          <a:p>
+            <a:endParaRPr lang="en-US"/>
+          </a:p>
+        </p:txBody>
+      </p:sp>
+      <p:sp>
+        <p:nvSpPr>
+          <p:cNvPr id="3" name="Shape 1"/>
+          <p:cNvSpPr/>
+          <p:nvPr/>
+        </p:nvSpPr>
+        <p:spPr>
+          <a:xfrm>
+            <a:off x="10469880" y="-658368"/>
+            <a:ext cx="2423160" cy="2423160"/>
+          </a:xfrm>
+          <a:prstGeom prst="ellipse">
+            <a:avLst/>
+          </a:prstGeom>
+          <a:solidFill>
+            <a:srgbClr val="1E224E">
+              <a:alpha val="0"/>
+            </a:srgbClr>
+          </a:solidFill>
+          <a:ln w="12700">
+            <a:solidFill>
+              <a:srgbClr val="2F78D8">
+                <a:alpha val="42000"/>
+              </a:srgbClr>
+            </a:solidFill>
+            <a:prstDash val="solid"/>
+          </a:ln>
+        </p:spPr>
+        <p:txBody>
+          <a:bodyPr/>
+          <a:lstStyle/>
+          <a:p>
+            <a:endParaRPr lang="en-US"/>
+          </a:p>
+        </p:txBody>
+      </p:sp>
+      <p:sp>
+        <p:nvSpPr>
+          <p:cNvPr id="4" name="Shape 2"/>
+          <p:cNvSpPr/>
+          <p:nvPr/>
+        </p:nvSpPr>
+        <p:spPr>
+          <a:xfrm>
+            <a:off x="11109960" y="594360"/>
+            <a:ext cx="73152" cy="73152"/>
+          </a:xfrm>
+          <a:prstGeom prst="ellipse">
+            <a:avLst/>
+          </a:prstGeom>
+          <a:solidFill>
+            <a:srgbClr val="68E1E8"/>
+          </a:solidFill>
+          <a:ln w="12700">
+            <a:solidFill>
+              <a:srgbClr val="68E1E8">
+                <a:alpha val="0"/>
+              </a:srgbClr>
+            </a:solidFill>
+            <a:prstDash val="solid"/>
+          </a:ln>
+        </p:spPr>
+        <p:txBody>
+          <a:bodyPr/>
+          <a:lstStyle/>
+          <a:p>
+            <a:endParaRPr lang="en-US"/>
+          </a:p>
+        </p:txBody>
+      </p:sp>
+      <p:sp>
+        <p:nvSpPr>
+          <p:cNvPr id="5" name="Shape 3"/>
+          <p:cNvSpPr/>
+          <p:nvPr/>
+        </p:nvSpPr>
+        <p:spPr>
+          <a:xfrm>
+            <a:off x="11384280" y="850392"/>
+            <a:ext cx="45720" cy="45720"/>
+          </a:xfrm>
+          <a:prstGeom prst="ellipse">
+            <a:avLst/>
+          </a:prstGeom>
+          <a:solidFill>
+            <a:srgbClr val="39C6D8"/>
+          </a:solidFill>
+          <a:ln w="12700">
+            <a:solidFill>
+              <a:srgbClr val="39C6D8">
+                <a:alpha val="0"/>
+              </a:srgbClr>
+            </a:solidFill>
+            <a:prstDash val="solid"/>
+          </a:ln>
+        </p:spPr>
+        <p:txBody>
+          <a:bodyPr/>
+          <a:lstStyle/>
+          <a:p>
+            <a:endParaRPr lang="en-US"/>
+          </a:p>
+        </p:txBody>
+      </p:sp>
+      <p:sp>
+        <p:nvSpPr>
+          <p:cNvPr id="6" name="Shape 4"/>
+          <p:cNvSpPr/>
+          <p:nvPr/>
+        </p:nvSpPr>
+        <p:spPr>
+          <a:xfrm>
+            <a:off x="11631168" y="1106424"/>
+            <a:ext cx="36576" cy="36576"/>
+          </a:xfrm>
+          <a:prstGeom prst="ellipse">
+            <a:avLst/>
+          </a:prstGeom>
+          <a:solidFill>
+            <a:srgbClr val="2F78D8"/>
+          </a:solidFill>
+          <a:ln w="12700">
+            <a:solidFill>
+              <a:srgbClr val="2F78D8">
+                <a:alpha val="0"/>
+              </a:srgbClr>
+            </a:solidFill>
+            <a:prstDash val="solid"/>
+          </a:ln>
+        </p:spPr>
+        <p:txBody>
+          <a:bodyPr/>
+          <a:lstStyle/>
+          <a:p>
+            <a:endParaRPr lang="en-US"/>
+          </a:p>
+        </p:txBody>
+      </p:sp>
+      <p:sp>
+        <p:nvSpPr>
+          <p:cNvPr id="7" name="Shape 5"/>
+          <p:cNvSpPr/>
+          <p:nvPr/>
+        </p:nvSpPr>
+        <p:spPr>
+          <a:xfrm>
+            <a:off x="-1371600" y="5166360"/>
+            <a:ext cx="2926080" cy="2926080"/>
+          </a:xfrm>
+          <a:prstGeom prst="ellipse">
+            <a:avLst/>
+          </a:prstGeom>
+          <a:solidFill>
+            <a:srgbClr val="1E224E">
+              <a:alpha val="0"/>
+            </a:srgbClr>
+          </a:solidFill>
+          <a:ln w="12700">
+            <a:solidFill>
+              <a:srgbClr val="39C6D8">
+                <a:alpha val="26000"/>
+              </a:srgbClr>
+            </a:solidFill>
+            <a:prstDash val="solid"/>
+          </a:ln>
+        </p:spPr>
+        <p:txBody>
+          <a:bodyPr/>
+          <a:lstStyle/>
+          <a:p>
+            <a:endParaRPr lang="en-US"/>
+          </a:p>
+        </p:txBody>
+      </p:sp>
+      <p:sp>
+        <p:nvSpPr>
+          <p:cNvPr id="8" name="TextBox 7"/>
+          <p:cNvSpPr txBox="1"/>
+          <p:nvPr/>
+        </p:nvSpPr>
+        <p:spPr>
+          <a:xfrm>
+            <a:off x="594360" y="502920"/>
+            <a:ext cx="7315200" cy="256032"/>
+          </a:xfrm>
+          <a:prstGeom prst="rect">
+            <a:avLst/>
+          </a:prstGeom>
+          <a:noFill/>
+        </p:spPr>
+        <p:txBody>
+          <a:bodyPr wrap="square" lIns="0" tIns="0" rIns="0" bIns="0">
+            <a:spAutoFit/>
+          </a:bodyPr>
+          <a:lstStyle/>
+          <a:p>
+            <a:pPr>
+              <a:spcAft>
+                <a:spcPts val="900"/>
+              </a:spcAft>
+            </a:pPr>
+            <a:r>
+              <a:rPr sz="1100" b="1">
+                <a:solidFill>
+                  <a:srgbClr val="39C6D8"/>
+                </a:solidFill>
+                <a:latin typeface="Carlito"/>
+              </a:rPr>
+              <a:t>WORKSHOP SETUP</a:t>
+            </a:r>
+          </a:p>
+        </p:txBody>
+      </p:sp>
+      <p:sp>
+        <p:nvSpPr>
+          <p:cNvPr id="9" name="TextBox 8"/>
+          <p:cNvSpPr txBox="1"/>
+          <p:nvPr/>
+        </p:nvSpPr>
+        <p:spPr>
+          <a:xfrm>
+            <a:off x="594360" y="868680"/>
+            <a:ext cx="10698480" cy="430887"/>
+          </a:xfrm>
+          <a:prstGeom prst="rect">
+            <a:avLst/>
+          </a:prstGeom>
+          <a:noFill/>
+        </p:spPr>
+        <p:txBody>
+          <a:bodyPr wrap="square" lIns="0" tIns="0" rIns="0" bIns="0">
+            <a:spAutoFit/>
+          </a:bodyPr>
+          <a:lstStyle/>
+          <a:p>
+            <a:pPr>
+              <a:spcAft>
+                <a:spcPts val="900"/>
+              </a:spcAft>
+            </a:pPr>
+            <a:r>
+              <a:rPr sz="2800" b="1" dirty="0">
+                <a:solidFill>
+                  <a:srgbClr val="F8FBFF"/>
+                </a:solidFill>
+                <a:latin typeface="Carlito"/>
+              </a:rPr>
+              <a:t>Bring your own Windows VM</a:t>
+            </a:r>
+            <a:r>
+              <a:rPr lang="en-GB" sz="2800" b="1" dirty="0">
+                <a:solidFill>
+                  <a:srgbClr val="F8FBFF"/>
+                </a:solidFill>
+              </a:rPr>
+              <a:t> http://aka.ms/AA13mnds</a:t>
+            </a:r>
+            <a:endParaRPr sz="2800" b="1" dirty="0">
+              <a:solidFill>
+                <a:srgbClr val="F8FBFF"/>
+              </a:solidFill>
+              <a:latin typeface="Carlito"/>
+            </a:endParaRPr>
+          </a:p>
+        </p:txBody>
+      </p:sp>
+      <p:sp>
+        <p:nvSpPr>
+          <p:cNvPr id="10" name="TextBox 9"/>
+          <p:cNvSpPr txBox="1"/>
+          <p:nvPr/>
+        </p:nvSpPr>
+        <p:spPr>
+          <a:xfrm>
+            <a:off x="612648" y="1527048"/>
+            <a:ext cx="10698480" cy="365760"/>
+          </a:xfrm>
+          <a:prstGeom prst="rect">
+            <a:avLst/>
+          </a:prstGeom>
+          <a:noFill/>
+        </p:spPr>
+        <p:txBody>
+          <a:bodyPr wrap="square" lIns="0" tIns="0" rIns="0" bIns="0">
+            <a:spAutoFit/>
+          </a:bodyPr>
+          <a:lstStyle/>
+          <a:p>
+            <a:pPr>
+              <a:spcAft>
+                <a:spcPts val="900"/>
+              </a:spcAft>
+            </a:pPr>
+            <a:r>
+              <a:rPr sz="1400" b="0">
+                <a:solidFill>
+                  <a:srgbClr val="AAB7D8"/>
+                </a:solidFill>
+                <a:latin typeface="Carlito"/>
+              </a:rPr>
+              <a:t>Create the VM on your platform, then prepare the workshop inside Windows.</a:t>
+            </a:r>
+          </a:p>
+        </p:txBody>
+      </p:sp>
+      <p:sp>
+        <p:nvSpPr>
+          <p:cNvPr id="11" name="TextBox 10"/>
+          <p:cNvSpPr txBox="1"/>
+          <p:nvPr/>
+        </p:nvSpPr>
+        <p:spPr>
+          <a:xfrm>
+            <a:off x="658368" y="2103120"/>
+            <a:ext cx="5074920" cy="365760"/>
+          </a:xfrm>
+          <a:prstGeom prst="rect">
+            <a:avLst/>
+          </a:prstGeom>
+          <a:noFill/>
+        </p:spPr>
+        <p:txBody>
+          <a:bodyPr wrap="square" lIns="0" tIns="0" rIns="0" bIns="0">
+            <a:spAutoFit/>
+          </a:bodyPr>
+          <a:lstStyle/>
+          <a:p>
+            <a:pPr>
+              <a:spcAft>
+                <a:spcPts val="900"/>
+              </a:spcAft>
+            </a:pPr>
+            <a:r>
+              <a:rPr sz="2100" b="1">
+                <a:solidFill>
+                  <a:srgbClr val="F8FBFF"/>
+                </a:solidFill>
+                <a:latin typeface="Carlito"/>
+              </a:rPr>
+              <a:t>Mac with UTM</a:t>
+            </a:r>
+          </a:p>
+        </p:txBody>
+      </p:sp>
+      <p:sp>
+        <p:nvSpPr>
+          <p:cNvPr id="12" name="TextBox 11"/>
+          <p:cNvSpPr txBox="1"/>
+          <p:nvPr/>
+        </p:nvSpPr>
+        <p:spPr>
+          <a:xfrm>
+            <a:off x="658368" y="2642616"/>
+            <a:ext cx="5047488" cy="1691640"/>
+          </a:xfrm>
+          <a:prstGeom prst="rect">
+            <a:avLst/>
+          </a:prstGeom>
+          <a:noFill/>
+        </p:spPr>
+        <p:txBody>
+          <a:bodyPr wrap="square" lIns="0" tIns="0" rIns="0" bIns="0">
+            <a:spAutoFit/>
+          </a:bodyPr>
+          <a:lstStyle/>
+          <a:p>
+            <a:pPr>
+              <a:spcAft>
+                <a:spcPts val="900"/>
+              </a:spcAft>
+            </a:pPr>
+            <a:r>
+              <a:rPr sz="1600" b="0">
+                <a:solidFill>
+                  <a:srgbClr val="AAB7D8"/>
+                </a:solidFill>
+                <a:latin typeface="Carlito"/>
+              </a:rPr>
+              <a:t>1  Download a Windows 11 ISO matching your Mac: ARM64 for Apple silicon, x64 for Intel.</a:t>
+            </a:r>
+          </a:p>
+          <a:p>
+            <a:pPr>
+              <a:spcAft>
+                <a:spcPts val="900"/>
+              </a:spcAft>
+            </a:pPr>
+            <a:r>
+              <a:rPr sz="1600" b="0">
+                <a:solidFill>
+                  <a:srgbClr val="AAB7D8"/>
+                </a:solidFill>
+                <a:latin typeface="Carlito"/>
+              </a:rPr>
+              <a:t>2  In UTM, choose Virtualize, then Windows. Attach the ISO and enable drivers / SPICE tools.</a:t>
+            </a:r>
+          </a:p>
+          <a:p>
+            <a:pPr>
+              <a:spcAft>
+                <a:spcPts val="900"/>
+              </a:spcAft>
+            </a:pPr>
+            <a:r>
+              <a:rPr sz="1600" b="0">
+                <a:solidFill>
+                  <a:srgbClr val="AAB7D8"/>
+                </a:solidFill>
+                <a:latin typeface="Carlito"/>
+              </a:rPr>
+              <a:t>3  Allocate RAM, CPU and disk, then install Windows.</a:t>
+            </a:r>
+          </a:p>
+        </p:txBody>
+      </p:sp>
+      <p:sp>
+        <p:nvSpPr>
+          <p:cNvPr id="13" name="TextBox 12"/>
+          <p:cNvSpPr txBox="1"/>
+          <p:nvPr/>
+        </p:nvSpPr>
+        <p:spPr>
+          <a:xfrm>
+            <a:off x="6327648" y="2103120"/>
+            <a:ext cx="5074920" cy="365760"/>
+          </a:xfrm>
+          <a:prstGeom prst="rect">
+            <a:avLst/>
+          </a:prstGeom>
+          <a:noFill/>
+        </p:spPr>
+        <p:txBody>
+          <a:bodyPr wrap="square" lIns="0" tIns="0" rIns="0" bIns="0">
+            <a:spAutoFit/>
+          </a:bodyPr>
+          <a:lstStyle/>
+          <a:p>
+            <a:pPr>
+              <a:spcAft>
+                <a:spcPts val="900"/>
+              </a:spcAft>
+            </a:pPr>
+            <a:r>
+              <a:rPr sz="2100" b="1">
+                <a:solidFill>
+                  <a:srgbClr val="F8FBFF"/>
+                </a:solidFill>
+                <a:latin typeface="Carlito"/>
+              </a:rPr>
+              <a:t>Windows with Hyper-V</a:t>
+            </a:r>
+          </a:p>
+        </p:txBody>
+      </p:sp>
+      <p:sp>
+        <p:nvSpPr>
+          <p:cNvPr id="14" name="TextBox 13"/>
+          <p:cNvSpPr txBox="1"/>
+          <p:nvPr/>
+        </p:nvSpPr>
+        <p:spPr>
+          <a:xfrm>
+            <a:off x="6327648" y="2642616"/>
+            <a:ext cx="5074920" cy="1691640"/>
+          </a:xfrm>
+          <a:prstGeom prst="rect">
+            <a:avLst/>
+          </a:prstGeom>
+          <a:noFill/>
+        </p:spPr>
+        <p:txBody>
+          <a:bodyPr wrap="square" lIns="0" tIns="0" rIns="0" bIns="0">
+            <a:spAutoFit/>
+          </a:bodyPr>
+          <a:lstStyle/>
+          <a:p>
+            <a:pPr>
+              <a:spcAft>
+                <a:spcPts val="900"/>
+              </a:spcAft>
+            </a:pPr>
+            <a:r>
+              <a:rPr sz="1600" b="0">
+                <a:solidFill>
+                  <a:srgbClr val="AAB7D8"/>
+                </a:solidFill>
+                <a:latin typeface="Carlito"/>
+              </a:rPr>
+              <a:t>1  Enable Hyper-V on a supported Windows host. In Hyper-V Manager, select New, Virtual Machine.</a:t>
+            </a:r>
+          </a:p>
+          <a:p>
+            <a:pPr>
+              <a:spcAft>
+                <a:spcPts val="900"/>
+              </a:spcAft>
+            </a:pPr>
+            <a:r>
+              <a:rPr sz="1600" b="0">
+                <a:solidFill>
+                  <a:srgbClr val="AAB7D8"/>
+                </a:solidFill>
+                <a:latin typeface="Carlito"/>
+              </a:rPr>
+              <a:t>2  Choose Generation 2. Assign memory, a virtual disk, network and a Windows 11 ISO.</a:t>
+            </a:r>
+          </a:p>
+          <a:p>
+            <a:pPr>
+              <a:spcAft>
+                <a:spcPts val="900"/>
+              </a:spcAft>
+            </a:pPr>
+            <a:r>
+              <a:rPr sz="1600" b="0">
+                <a:solidFill>
+                  <a:srgbClr val="AAB7D8"/>
+                </a:solidFill>
+                <a:latin typeface="Carlito"/>
+              </a:rPr>
+              <a:t>3  Enable Secure Boot and TPM, then install Windows.</a:t>
+            </a:r>
+          </a:p>
+        </p:txBody>
+      </p:sp>
+      <p:sp>
+        <p:nvSpPr>
+          <p:cNvPr id="15" name="TextBox 14"/>
+          <p:cNvSpPr txBox="1"/>
+          <p:nvPr/>
+        </p:nvSpPr>
+        <p:spPr>
+          <a:xfrm>
+            <a:off x="658368" y="4507992"/>
+            <a:ext cx="10789920" cy="320040"/>
+          </a:xfrm>
+          <a:prstGeom prst="rect">
+            <a:avLst/>
+          </a:prstGeom>
+          <a:noFill/>
+        </p:spPr>
+        <p:txBody>
+          <a:bodyPr wrap="square" lIns="0" tIns="0" rIns="0" bIns="0">
+            <a:spAutoFit/>
+          </a:bodyPr>
+          <a:lstStyle/>
+          <a:p>
+            <a:pPr>
+              <a:spcAft>
+                <a:spcPts val="900"/>
+              </a:spcAft>
+            </a:pPr>
+            <a:r>
+              <a:rPr sz="1800" b="1">
+                <a:solidFill>
+                  <a:srgbClr val="39C6D8"/>
+                </a:solidFill>
+                <a:latin typeface="Carlito"/>
+              </a:rPr>
+              <a:t>Inside the VM: prepare online, then test offline</a:t>
+            </a:r>
+          </a:p>
+        </p:txBody>
+      </p:sp>
+      <p:sp>
+        <p:nvSpPr>
+          <p:cNvPr id="16" name="TextBox 15"/>
+          <p:cNvSpPr txBox="1"/>
+          <p:nvPr/>
+        </p:nvSpPr>
+        <p:spPr>
+          <a:xfrm>
+            <a:off x="658368" y="4956048"/>
+            <a:ext cx="6629400" cy="777240"/>
+          </a:xfrm>
+          <a:prstGeom prst="rect">
+            <a:avLst/>
+          </a:prstGeom>
+          <a:noFill/>
+        </p:spPr>
+        <p:txBody>
+          <a:bodyPr wrap="square" lIns="0" tIns="0" rIns="0" bIns="0">
+            <a:spAutoFit/>
+          </a:bodyPr>
+          <a:lstStyle/>
+          <a:p>
+            <a:pPr>
+              <a:spcAft>
+                <a:spcPts val="900"/>
+              </a:spcAft>
+            </a:pPr>
+            <a:r>
+              <a:rPr sz="1500" b="0">
+                <a:solidFill>
+                  <a:srgbClr val="AAB7D8"/>
+                </a:solidFill>
+                <a:latin typeface="Carlito"/>
+              </a:rPr>
+              <a:t>Install Python 3.11+ and VS Code. Clone the repo, then follow docs/vm-image-runbook.md to install dependencies and cache the model.</a:t>
+            </a:r>
+          </a:p>
+        </p:txBody>
+      </p:sp>
+      <p:sp>
+        <p:nvSpPr>
+          <p:cNvPr id="17" name="TextBox 16"/>
+          <p:cNvSpPr txBox="1"/>
+          <p:nvPr/>
+        </p:nvSpPr>
+        <p:spPr>
+          <a:xfrm>
+            <a:off x="7772400" y="4965192"/>
+            <a:ext cx="3794760" cy="594360"/>
+          </a:xfrm>
+          <a:prstGeom prst="rect">
+            <a:avLst/>
+          </a:prstGeom>
+          <a:noFill/>
+        </p:spPr>
+        <p:txBody>
+          <a:bodyPr wrap="square" lIns="0" tIns="0" rIns="0" bIns="0">
+            <a:spAutoFit/>
+          </a:bodyPr>
+          <a:lstStyle/>
+          <a:p>
+            <a:pPr>
+              <a:spcAft>
+                <a:spcPts val="900"/>
+              </a:spcAft>
+            </a:pPr>
+            <a:r>
+              <a:rPr sz="1500" b="0">
+                <a:solidFill>
+                  <a:srgbClr val="D9E5FF"/>
+                </a:solidFill>
+                <a:latin typeface="Courier New"/>
+              </a:rPr>
+              <a:t>.\workshop.ps1 check</a:t>
+            </a:r>
+          </a:p>
+        </p:txBody>
+      </p:sp>
+      <p:sp>
+        <p:nvSpPr>
+          <p:cNvPr id="18" name="TextBox 17"/>
+          <p:cNvSpPr txBox="1"/>
+          <p:nvPr/>
+        </p:nvSpPr>
+        <p:spPr>
+          <a:xfrm>
+            <a:off x="7772400" y="5404104"/>
+            <a:ext cx="3749039" cy="274320"/>
+          </a:xfrm>
+          <a:prstGeom prst="rect">
+            <a:avLst/>
+          </a:prstGeom>
+          <a:noFill/>
+        </p:spPr>
+        <p:txBody>
+          <a:bodyPr wrap="square" lIns="0" tIns="0" rIns="0" bIns="0">
+            <a:spAutoFit/>
+          </a:bodyPr>
+          <a:lstStyle/>
+          <a:p>
+            <a:pPr>
+              <a:spcAft>
+                <a:spcPts val="900"/>
+              </a:spcAft>
+            </a:pPr>
+            <a:r>
+              <a:rPr sz="1200" b="0">
+                <a:solidFill>
+                  <a:srgbClr val="AAB7D8"/>
+                </a:solidFill>
+                <a:latin typeface="Carlito"/>
+              </a:rPr>
+              <a:t>Run from the repo with networking off.</a:t>
+            </a:r>
+          </a:p>
+        </p:txBody>
+      </p:sp>
+      <p:sp>
+        <p:nvSpPr>
+          <p:cNvPr id="19" name="TextBox 18"/>
+          <p:cNvSpPr txBox="1"/>
+          <p:nvPr/>
+        </p:nvSpPr>
+        <p:spPr>
+          <a:xfrm>
+            <a:off x="658368" y="5897880"/>
+            <a:ext cx="10789920" cy="274320"/>
+          </a:xfrm>
+          <a:prstGeom prst="rect">
+            <a:avLst/>
+          </a:prstGeom>
+          <a:noFill/>
+        </p:spPr>
+        <p:txBody>
+          <a:bodyPr wrap="square" lIns="0" tIns="0" rIns="0" bIns="0">
+            <a:spAutoFit/>
+          </a:bodyPr>
+          <a:lstStyle/>
+          <a:p>
+            <a:pPr>
+              <a:spcAft>
+                <a:spcPts val="900"/>
+              </a:spcAft>
+            </a:pPr>
+            <a:r>
+              <a:rPr sz="1200" b="0">
+                <a:solidFill>
+                  <a:srgbClr val="F8FBFF"/>
+                </a:solidFill>
+                <a:latin typeface="Carlito"/>
+              </a:rPr>
+              <a:t>UTM / Windows ARM workshop compatibility is unverified. Pass all checks before the event.</a:t>
+            </a:r>
+          </a:p>
+        </p:txBody>
+      </p:sp>
+      <p:sp>
+        <p:nvSpPr>
+          <p:cNvPr id="20" name="TextBox 19"/>
+          <p:cNvSpPr txBox="1"/>
+          <p:nvPr/>
+        </p:nvSpPr>
+        <p:spPr>
+          <a:xfrm>
+            <a:off x="658368" y="6272784"/>
+            <a:ext cx="10789920" cy="228600"/>
+          </a:xfrm>
+          <a:prstGeom prst="rect">
+            <a:avLst/>
+          </a:prstGeom>
+          <a:noFill/>
+        </p:spPr>
+        <p:txBody>
+          <a:bodyPr wrap="square" lIns="0" tIns="0" rIns="0" bIns="0">
+            <a:spAutoFit/>
+          </a:bodyPr>
+          <a:lstStyle/>
+          <a:p>
+            <a:pPr>
+              <a:spcAft>
+                <a:spcPts val="900"/>
+              </a:spcAft>
+            </a:pPr>
+            <a:r>
+              <a:rPr sz="1100" b="0">
+                <a:solidFill>
+                  <a:srgbClr val="39C6D8"/>
+                </a:solidFill>
+                <a:latin typeface="Carlito"/>
+                <a:hlinkClick r:id="rId3"/>
+              </a:rPr>
+              <a:t>github.com/GlobalAICommunity/mcp-fl-workshop</a:t>
+            </a:r>
+          </a:p>
+        </p:txBody>
+      </p:sp>
+      <p:sp>
+        <p:nvSpPr>
+          <p:cNvPr id="21" name="TextBox 20"/>
+          <p:cNvSpPr txBox="1"/>
+          <p:nvPr/>
+        </p:nvSpPr>
+        <p:spPr>
+          <a:xfrm>
+            <a:off x="2880360" y="2157984"/>
+            <a:ext cx="2743200" cy="276999"/>
+          </a:xfrm>
+          <a:prstGeom prst="rect">
+            <a:avLst/>
+          </a:prstGeom>
+          <a:noFill/>
+        </p:spPr>
+        <p:txBody>
+          <a:bodyPr wrap="square" lIns="0" tIns="0" rIns="0" bIns="0">
+            <a:spAutoFit/>
+          </a:bodyPr>
+          <a:lstStyle/>
+          <a:p>
+            <a:r>
+              <a:rPr u="sng" dirty="0" err="1">
+                <a:solidFill>
+                  <a:srgbClr val="39C6D8"/>
+                </a:solidFill>
+                <a:latin typeface="Carlito"/>
+              </a:rPr>
+              <a:t>mac.getutm.app</a:t>
+            </a:r>
+            <a:endParaRPr u="sng" dirty="0">
+              <a:solidFill>
+                <a:srgbClr val="39C6D8"/>
+              </a:solidFill>
+              <a:latin typeface="Carlito"/>
+            </a:endParaRPr>
+          </a:p>
+        </p:txBody>
+      </p:sp>
+    </p:spTree>
+    <p:extLst>
+      <p:ext uri="{BB962C8B-B14F-4D97-AF65-F5344CB8AC3E}">
+        <p14:creationId xmlns:p14="http://schemas.microsoft.com/office/powerpoint/2010/main" val="3404742548"/>
+      </p:ext>
+    </p:extLst>
+  </p:cSld>
+  <p:clrMapOvr>
+    <a:masterClrMapping/>
+  </p:clrMapOvr>
+</p:sld>
+</file>
+
+<file path=ppt/slides/slide7.xml><?xml version="1.0" encoding="utf-8"?>
+<p:sld xmlns:a="http://schemas.openxmlformats.org/drawingml/2006/main" xmlns:r="http://schemas.openxmlformats.org/officeDocument/2006/relationships" xmlns:p="http://schemas.openxmlformats.org/presentationml/2006/main">
+  <p:cSld>
+    <p:spTree>
+      <p:nvGrpSpPr>
+        <p:cNvPr id="1" name=""/>
+        <p:cNvGrpSpPr/>
+        <p:nvPr/>
+      </p:nvGrpSpPr>
+      <p:grpSpPr>
+        <a:xfrm>
+          <a:off x="0" y="0"/>
+          <a:ext cx="0" cy="0"/>
+          <a:chOff x="0" y="0"/>
+          <a:chExt cx="0" cy="0"/>
+        </a:xfrm>
+      </p:grpSpPr>
+      <p:sp>
+        <p:nvSpPr>
+          <p:cNvPr id="2" name="Shape 0"/>
+          <p:cNvSpPr/>
+          <p:nvPr/>
+        </p:nvSpPr>
+        <p:spPr>
+          <a:xfrm>
+            <a:off x="9966960" y="-1143000"/>
+            <a:ext cx="3383280" cy="3383280"/>
+          </a:xfrm>
+          <a:prstGeom prst="ellipse">
+            <a:avLst/>
+          </a:prstGeom>
+          <a:solidFill>
+            <a:srgbClr val="1E224E">
+              <a:alpha val="0"/>
+            </a:srgbClr>
+          </a:solidFill>
+          <a:ln w="16510">
+            <a:solidFill>
+              <a:srgbClr val="39C6D8">
+                <a:alpha val="38000"/>
+              </a:srgbClr>
+            </a:solidFill>
+            <a:prstDash val="solid"/>
+          </a:ln>
+        </p:spPr>
+        <p:txBody>
+          <a:bodyPr/>
+          <a:lstStyle/>
+          <a:p>
+            <a:endParaRPr lang="en-US"/>
+          </a:p>
+        </p:txBody>
+      </p:sp>
+      <p:sp>
+        <p:nvSpPr>
+          <p:cNvPr id="3" name="Shape 1"/>
+          <p:cNvSpPr/>
+          <p:nvPr/>
+        </p:nvSpPr>
+        <p:spPr>
+          <a:xfrm>
+            <a:off x="10469880" y="-658368"/>
+            <a:ext cx="2423160" cy="2423160"/>
+          </a:xfrm>
+          <a:prstGeom prst="ellipse">
+            <a:avLst/>
+          </a:prstGeom>
+          <a:solidFill>
+            <a:srgbClr val="1E224E">
+              <a:alpha val="0"/>
+            </a:srgbClr>
+          </a:solidFill>
+          <a:ln w="12700">
+            <a:solidFill>
+              <a:srgbClr val="2F78D8">
+                <a:alpha val="42000"/>
+              </a:srgbClr>
+            </a:solidFill>
+            <a:prstDash val="solid"/>
+          </a:ln>
+        </p:spPr>
+        <p:txBody>
+          <a:bodyPr/>
+          <a:lstStyle/>
+          <a:p>
+            <a:endParaRPr lang="en-US"/>
+          </a:p>
+        </p:txBody>
+      </p:sp>
+      <p:sp>
+        <p:nvSpPr>
+          <p:cNvPr id="4" name="Shape 2"/>
+          <p:cNvSpPr/>
+          <p:nvPr/>
+        </p:nvSpPr>
+        <p:spPr>
+          <a:xfrm>
+            <a:off x="11109960" y="594360"/>
+            <a:ext cx="73152" cy="73152"/>
+          </a:xfrm>
+          <a:prstGeom prst="ellipse">
+            <a:avLst/>
+          </a:prstGeom>
+          <a:solidFill>
+            <a:srgbClr val="68E1E8"/>
+          </a:solidFill>
+          <a:ln w="12700">
+            <a:solidFill>
+              <a:srgbClr val="68E1E8">
+                <a:alpha val="0"/>
+              </a:srgbClr>
+            </a:solidFill>
+            <a:prstDash val="solid"/>
+          </a:ln>
+        </p:spPr>
+        <p:txBody>
+          <a:bodyPr/>
+          <a:lstStyle/>
+          <a:p>
+            <a:endParaRPr lang="en-US"/>
+          </a:p>
+        </p:txBody>
+      </p:sp>
+      <p:sp>
+        <p:nvSpPr>
+          <p:cNvPr id="5" name="Shape 3"/>
+          <p:cNvSpPr/>
+          <p:nvPr/>
+        </p:nvSpPr>
+        <p:spPr>
+          <a:xfrm>
+            <a:off x="11384280" y="850392"/>
+            <a:ext cx="45720" cy="45720"/>
+          </a:xfrm>
+          <a:prstGeom prst="ellipse">
+            <a:avLst/>
+          </a:prstGeom>
+          <a:solidFill>
+            <a:srgbClr val="39C6D8"/>
+          </a:solidFill>
+          <a:ln w="12700">
+            <a:solidFill>
+              <a:srgbClr val="39C6D8">
+                <a:alpha val="0"/>
+              </a:srgbClr>
+            </a:solidFill>
+            <a:prstDash val="solid"/>
+          </a:ln>
+        </p:spPr>
+        <p:txBody>
+          <a:bodyPr/>
+          <a:lstStyle/>
+          <a:p>
+            <a:endParaRPr lang="en-US"/>
+          </a:p>
+        </p:txBody>
+      </p:sp>
+      <p:sp>
+        <p:nvSpPr>
+          <p:cNvPr id="6" name="Shape 4"/>
+          <p:cNvSpPr/>
+          <p:nvPr/>
+        </p:nvSpPr>
+        <p:spPr>
+          <a:xfrm>
+            <a:off x="11631168" y="1106424"/>
+            <a:ext cx="36576" cy="36576"/>
+          </a:xfrm>
+          <a:prstGeom prst="ellipse">
+            <a:avLst/>
+          </a:prstGeom>
+          <a:solidFill>
+            <a:srgbClr val="2F78D8"/>
+          </a:solidFill>
+          <a:ln w="12700">
+            <a:solidFill>
+              <a:srgbClr val="2F78D8">
+                <a:alpha val="0"/>
+              </a:srgbClr>
+            </a:solidFill>
+            <a:prstDash val="solid"/>
+          </a:ln>
+        </p:spPr>
+        <p:txBody>
+          <a:bodyPr/>
+          <a:lstStyle/>
+          <a:p>
+            <a:endParaRPr lang="en-US"/>
+          </a:p>
+        </p:txBody>
+      </p:sp>
+      <p:sp>
+        <p:nvSpPr>
+          <p:cNvPr id="7" name="Shape 5"/>
+          <p:cNvSpPr/>
+          <p:nvPr/>
+        </p:nvSpPr>
+        <p:spPr>
+          <a:xfrm>
+            <a:off x="-1371600" y="5166360"/>
+            <a:ext cx="2926080" cy="2926080"/>
+          </a:xfrm>
+          <a:prstGeom prst="ellipse">
+            <a:avLst/>
+          </a:prstGeom>
+          <a:solidFill>
+            <a:srgbClr val="1E224E">
+              <a:alpha val="0"/>
+            </a:srgbClr>
+          </a:solidFill>
+          <a:ln w="12700">
+            <a:solidFill>
+              <a:srgbClr val="39C6D8">
+                <a:alpha val="26000"/>
+              </a:srgbClr>
+            </a:solidFill>
+            <a:prstDash val="solid"/>
+          </a:ln>
+        </p:spPr>
+        <p:txBody>
+          <a:bodyPr/>
+          <a:lstStyle/>
+          <a:p>
+            <a:endParaRPr lang="en-US"/>
+          </a:p>
+        </p:txBody>
+      </p:sp>
+      <p:sp>
+        <p:nvSpPr>
+          <p:cNvPr id="8" name="TextBox 7"/>
+          <p:cNvSpPr txBox="1"/>
+          <p:nvPr/>
+        </p:nvSpPr>
+        <p:spPr>
+          <a:xfrm>
+            <a:off x="594360" y="502920"/>
+            <a:ext cx="7315200" cy="256032"/>
+          </a:xfrm>
+          <a:prstGeom prst="rect">
+            <a:avLst/>
+          </a:prstGeom>
+          <a:noFill/>
+        </p:spPr>
+        <p:txBody>
+          <a:bodyPr wrap="square" lIns="0" tIns="0" rIns="0" bIns="0">
+            <a:spAutoFit/>
+          </a:bodyPr>
+          <a:lstStyle/>
+          <a:p>
+            <a:pPr>
+              <a:spcAft>
+                <a:spcPts val="900"/>
+              </a:spcAft>
+            </a:pPr>
+            <a:r>
+              <a:rPr sz="1100" b="1">
+                <a:solidFill>
+                  <a:srgbClr val="39C6D8"/>
+                </a:solidFill>
+                <a:latin typeface="Carlito"/>
+              </a:rPr>
+              <a:t>WORKSHOP SETUP</a:t>
+            </a:r>
+          </a:p>
+        </p:txBody>
+      </p:sp>
+      <p:sp>
+        <p:nvSpPr>
+          <p:cNvPr id="9" name="TextBox 8"/>
+          <p:cNvSpPr txBox="1"/>
+          <p:nvPr/>
+        </p:nvSpPr>
+        <p:spPr>
+          <a:xfrm>
+            <a:off x="594360" y="868680"/>
+            <a:ext cx="10698480" cy="594360"/>
+          </a:xfrm>
+          <a:prstGeom prst="rect">
+            <a:avLst/>
+          </a:prstGeom>
+          <a:noFill/>
+        </p:spPr>
+        <p:txBody>
+          <a:bodyPr wrap="square" lIns="0" tIns="0" rIns="0" bIns="0">
+            <a:spAutoFit/>
+          </a:bodyPr>
+          <a:lstStyle/>
+          <a:p>
+            <a:pPr>
+              <a:spcAft>
+                <a:spcPts val="900"/>
+              </a:spcAft>
+            </a:pPr>
+            <a:r>
+              <a:rPr sz="2800" b="1">
+                <a:solidFill>
+                  <a:srgbClr val="F8FBFF"/>
+                </a:solidFill>
+                <a:latin typeface="Carlito"/>
+              </a:rPr>
+              <a:t>The workshop in GitHub Codespaces</a:t>
+            </a:r>
+          </a:p>
+        </p:txBody>
+      </p:sp>
+      <p:sp>
+        <p:nvSpPr>
+          <p:cNvPr id="10" name="TextBox 9"/>
+          <p:cNvSpPr txBox="1"/>
+          <p:nvPr/>
+        </p:nvSpPr>
+        <p:spPr>
+          <a:xfrm>
+            <a:off x="612648" y="1527048"/>
+            <a:ext cx="10698480" cy="457200"/>
+          </a:xfrm>
+          <a:prstGeom prst="rect">
+            <a:avLst/>
+          </a:prstGeom>
+          <a:noFill/>
+        </p:spPr>
+        <p:txBody>
+          <a:bodyPr wrap="square" lIns="0" tIns="0" rIns="0" bIns="0">
+            <a:spAutoFit/>
+          </a:bodyPr>
+          <a:lstStyle/>
+          <a:p>
+            <a:pPr>
+              <a:spcAft>
+                <a:spcPts val="900"/>
+              </a:spcAft>
+            </a:pPr>
+            <a:r>
+              <a:rPr sz="1400" b="0">
+                <a:solidFill>
+                  <a:srgbClr val="AAB7D8"/>
+                </a:solidFill>
+                <a:latin typeface="Carlito"/>
+              </a:rPr>
+              <a:t>Open the repository in your browser, then follow the Codespaces guide.</a:t>
+            </a:r>
+          </a:p>
+        </p:txBody>
+      </p:sp>
+      <p:sp>
+        <p:nvSpPr>
+          <p:cNvPr id="11" name="TextBox 10"/>
+          <p:cNvSpPr txBox="1"/>
+          <p:nvPr/>
+        </p:nvSpPr>
+        <p:spPr>
+          <a:xfrm>
+            <a:off x="658368" y="2240280"/>
+            <a:ext cx="640080" cy="548640"/>
+          </a:xfrm>
+          <a:prstGeom prst="rect">
+            <a:avLst/>
+          </a:prstGeom>
+          <a:noFill/>
+        </p:spPr>
+        <p:txBody>
+          <a:bodyPr wrap="square" lIns="0" tIns="0" rIns="0" bIns="0">
+            <a:spAutoFit/>
+          </a:bodyPr>
+          <a:lstStyle/>
+          <a:p>
+            <a:pPr>
+              <a:spcAft>
+                <a:spcPts val="900"/>
+              </a:spcAft>
+            </a:pPr>
+            <a:r>
+              <a:rPr sz="2400" b="1">
+                <a:solidFill>
+                  <a:srgbClr val="39C6D8"/>
+                </a:solidFill>
+                <a:latin typeface="Carlito"/>
+              </a:rPr>
+              <a:t>01</a:t>
+            </a:r>
+          </a:p>
+        </p:txBody>
+      </p:sp>
+      <p:sp>
+        <p:nvSpPr>
+          <p:cNvPr id="12" name="TextBox 11"/>
+          <p:cNvSpPr txBox="1"/>
+          <p:nvPr/>
+        </p:nvSpPr>
+        <p:spPr>
+          <a:xfrm>
+            <a:off x="1417320" y="2240280"/>
+            <a:ext cx="4572000" cy="365760"/>
+          </a:xfrm>
+          <a:prstGeom prst="rect">
+            <a:avLst/>
+          </a:prstGeom>
+          <a:noFill/>
+        </p:spPr>
+        <p:txBody>
+          <a:bodyPr wrap="square" lIns="0" tIns="0" rIns="0" bIns="0">
+            <a:spAutoFit/>
+          </a:bodyPr>
+          <a:lstStyle/>
+          <a:p>
+            <a:pPr>
+              <a:spcAft>
+                <a:spcPts val="900"/>
+              </a:spcAft>
+            </a:pPr>
+            <a:r>
+              <a:rPr sz="2100" b="1">
+                <a:solidFill>
+                  <a:srgbClr val="F8FBFF"/>
+                </a:solidFill>
+                <a:latin typeface="Carlito"/>
+              </a:rPr>
+              <a:t>Create your codespace</a:t>
+            </a:r>
+          </a:p>
+        </p:txBody>
+      </p:sp>
+      <p:sp>
+        <p:nvSpPr>
+          <p:cNvPr id="13" name="TextBox 12"/>
+          <p:cNvSpPr txBox="1"/>
+          <p:nvPr/>
+        </p:nvSpPr>
+        <p:spPr>
+          <a:xfrm>
+            <a:off x="1417320" y="2761488"/>
+            <a:ext cx="4480560" cy="1371600"/>
+          </a:xfrm>
+          <a:prstGeom prst="rect">
+            <a:avLst/>
+          </a:prstGeom>
+          <a:noFill/>
+        </p:spPr>
+        <p:txBody>
+          <a:bodyPr wrap="square" lIns="0" tIns="0" rIns="0" bIns="0">
+            <a:spAutoFit/>
+          </a:bodyPr>
+          <a:lstStyle/>
+          <a:p>
+            <a:pPr>
+              <a:spcAft>
+                <a:spcPts val="900"/>
+              </a:spcAft>
+            </a:pPr>
+            <a:r>
+              <a:rPr sz="1700" b="0">
+                <a:solidFill>
+                  <a:srgbClr val="AAB7D8"/>
+                </a:solidFill>
+                <a:latin typeface="Carlito"/>
+              </a:rPr>
+              <a:t>Sign in to GitHub and open the workshop repo.</a:t>
+            </a:r>
+          </a:p>
+          <a:p>
+            <a:pPr>
+              <a:spcAft>
+                <a:spcPts val="900"/>
+              </a:spcAft>
+            </a:pPr>
+            <a:r>
+              <a:rPr sz="1700" b="0">
+                <a:solidFill>
+                  <a:srgbClr val="AAB7D8"/>
+                </a:solidFill>
+                <a:latin typeface="Carlito"/>
+              </a:rPr>
+              <a:t>Select Code, then Codespaces, then Create codespace on main.</a:t>
+            </a:r>
+          </a:p>
+        </p:txBody>
+      </p:sp>
+      <p:sp>
+        <p:nvSpPr>
+          <p:cNvPr id="14" name="TextBox 13"/>
+          <p:cNvSpPr txBox="1"/>
+          <p:nvPr/>
+        </p:nvSpPr>
+        <p:spPr>
+          <a:xfrm>
+            <a:off x="6400800" y="2240280"/>
+            <a:ext cx="640080" cy="548640"/>
+          </a:xfrm>
+          <a:prstGeom prst="rect">
+            <a:avLst/>
+          </a:prstGeom>
+          <a:noFill/>
+        </p:spPr>
+        <p:txBody>
+          <a:bodyPr wrap="square" lIns="0" tIns="0" rIns="0" bIns="0">
+            <a:spAutoFit/>
+          </a:bodyPr>
+          <a:lstStyle/>
+          <a:p>
+            <a:pPr>
+              <a:spcAft>
+                <a:spcPts val="900"/>
+              </a:spcAft>
+            </a:pPr>
+            <a:r>
+              <a:rPr sz="2400" b="1">
+                <a:solidFill>
+                  <a:srgbClr val="39C6D8"/>
+                </a:solidFill>
+                <a:latin typeface="Carlito"/>
+              </a:rPr>
+              <a:t>02</a:t>
+            </a:r>
+          </a:p>
+        </p:txBody>
+      </p:sp>
+      <p:sp>
+        <p:nvSpPr>
+          <p:cNvPr id="15" name="TextBox 14"/>
+          <p:cNvSpPr txBox="1"/>
+          <p:nvPr/>
+        </p:nvSpPr>
+        <p:spPr>
+          <a:xfrm>
+            <a:off x="7159752" y="2240280"/>
+            <a:ext cx="4389120" cy="365760"/>
+          </a:xfrm>
+          <a:prstGeom prst="rect">
+            <a:avLst/>
+          </a:prstGeom>
+          <a:noFill/>
+        </p:spPr>
+        <p:txBody>
+          <a:bodyPr wrap="square" lIns="0" tIns="0" rIns="0" bIns="0">
+            <a:spAutoFit/>
+          </a:bodyPr>
+          <a:lstStyle/>
+          <a:p>
+            <a:pPr>
+              <a:spcAft>
+                <a:spcPts val="900"/>
+              </a:spcAft>
+            </a:pPr>
+            <a:r>
+              <a:rPr sz="2100" b="1">
+                <a:solidFill>
+                  <a:srgbClr val="F8FBFF"/>
+                </a:solidFill>
+                <a:latin typeface="Carlito"/>
+              </a:rPr>
+              <a:t>Follow the Codespaces guide</a:t>
+            </a:r>
+          </a:p>
+        </p:txBody>
+      </p:sp>
+      <p:sp>
+        <p:nvSpPr>
+          <p:cNvPr id="16" name="TextBox 15"/>
+          <p:cNvSpPr txBox="1"/>
+          <p:nvPr/>
+        </p:nvSpPr>
+        <p:spPr>
+          <a:xfrm>
+            <a:off x="7159752" y="2761488"/>
+            <a:ext cx="4343400" cy="1371600"/>
+          </a:xfrm>
+          <a:prstGeom prst="rect">
+            <a:avLst/>
+          </a:prstGeom>
+          <a:noFill/>
+        </p:spPr>
+        <p:txBody>
+          <a:bodyPr wrap="square" lIns="0" tIns="0" rIns="0" bIns="0">
+            <a:spAutoFit/>
+          </a:bodyPr>
+          <a:lstStyle/>
+          <a:p>
+            <a:pPr>
+              <a:spcAft>
+                <a:spcPts val="900"/>
+              </a:spcAft>
+            </a:pPr>
+            <a:r>
+              <a:rPr sz="1700" b="0">
+                <a:solidFill>
+                  <a:srgbClr val="AAB7D8"/>
+                </a:solidFill>
+                <a:latin typeface="Carlito"/>
+              </a:rPr>
+              <a:t>Wait for the editor to open.</a:t>
+            </a:r>
+          </a:p>
+          <a:p>
+            <a:pPr>
+              <a:spcAft>
+                <a:spcPts val="900"/>
+              </a:spcAft>
+            </a:pPr>
+            <a:r>
+              <a:rPr sz="1700" b="0">
+                <a:solidFill>
+                  <a:srgbClr val="AAB7D8"/>
+                </a:solidFill>
+                <a:latin typeface="Carlito"/>
+              </a:rPr>
+              <a:t>Open the guide below and follow its setup and run instructions in the terminal.</a:t>
+            </a:r>
+          </a:p>
+        </p:txBody>
+      </p:sp>
+      <p:sp>
+        <p:nvSpPr>
+          <p:cNvPr id="17" name="TextBox 16"/>
+          <p:cNvSpPr txBox="1"/>
+          <p:nvPr/>
+        </p:nvSpPr>
+        <p:spPr>
+          <a:xfrm>
+            <a:off x="658368" y="4498848"/>
+            <a:ext cx="10789920" cy="320040"/>
+          </a:xfrm>
+          <a:prstGeom prst="rect">
+            <a:avLst/>
+          </a:prstGeom>
+          <a:noFill/>
+        </p:spPr>
+        <p:txBody>
+          <a:bodyPr wrap="square" lIns="0" tIns="0" rIns="0" bIns="0">
+            <a:spAutoFit/>
+          </a:bodyPr>
+          <a:lstStyle/>
+          <a:p>
+            <a:pPr>
+              <a:spcAft>
+                <a:spcPts val="900"/>
+              </a:spcAft>
+            </a:pPr>
+            <a:r>
+              <a:rPr sz="1800" b="1">
+                <a:solidFill>
+                  <a:srgbClr val="39C6D8"/>
+                </a:solidFill>
+                <a:latin typeface="Carlito"/>
+              </a:rPr>
+              <a:t>Codespaces guide in the repository</a:t>
+            </a:r>
+          </a:p>
+        </p:txBody>
+      </p:sp>
+      <p:sp>
+        <p:nvSpPr>
+          <p:cNvPr id="18" name="TextBox 17"/>
+          <p:cNvSpPr txBox="1"/>
+          <p:nvPr/>
+        </p:nvSpPr>
+        <p:spPr>
+          <a:xfrm>
+            <a:off x="658368" y="5001768"/>
+            <a:ext cx="10789920" cy="502920"/>
+          </a:xfrm>
+          <a:prstGeom prst="rect">
+            <a:avLst/>
+          </a:prstGeom>
+          <a:noFill/>
+        </p:spPr>
+        <p:txBody>
+          <a:bodyPr wrap="square" lIns="0" tIns="0" rIns="0" bIns="0">
+            <a:spAutoFit/>
+          </a:bodyPr>
+          <a:lstStyle/>
+          <a:p>
+            <a:pPr>
+              <a:spcAft>
+                <a:spcPts val="900"/>
+              </a:spcAft>
+            </a:pPr>
+            <a:r>
+              <a:rPr sz="2400" b="1">
+                <a:solidFill>
+                  <a:srgbClr val="F8FBFF"/>
+                </a:solidFill>
+                <a:latin typeface="Courier New"/>
+              </a:rPr>
+              <a:t>docs/codespaces/README.md</a:t>
+            </a:r>
+          </a:p>
+        </p:txBody>
+      </p:sp>
+      <p:sp>
+        <p:nvSpPr>
+          <p:cNvPr id="19" name="TextBox 18"/>
+          <p:cNvSpPr txBox="1"/>
+          <p:nvPr/>
+        </p:nvSpPr>
+        <p:spPr>
+          <a:xfrm>
+            <a:off x="658368" y="5705856"/>
+            <a:ext cx="10789920" cy="369332"/>
+          </a:xfrm>
+          <a:prstGeom prst="rect">
+            <a:avLst/>
+          </a:prstGeom>
+          <a:noFill/>
+        </p:spPr>
+        <p:txBody>
+          <a:bodyPr wrap="square" lIns="0" tIns="0" rIns="0" bIns="0">
+            <a:spAutoFit/>
+          </a:bodyPr>
+          <a:lstStyle/>
+          <a:p>
+            <a:pPr>
+              <a:spcAft>
+                <a:spcPts val="900"/>
+              </a:spcAft>
+            </a:pPr>
+            <a:r>
+              <a:rPr sz="2400" b="0" dirty="0">
+                <a:solidFill>
+                  <a:schemeClr val="bg1"/>
+                </a:solidFill>
+                <a:latin typeface="Carlito"/>
+              </a:rPr>
+              <a:t>github.com/</a:t>
+            </a:r>
+            <a:r>
+              <a:rPr sz="2400" b="0" dirty="0" err="1">
+                <a:solidFill>
+                  <a:schemeClr val="bg1"/>
+                </a:solidFill>
+                <a:latin typeface="Carlito"/>
+              </a:rPr>
+              <a:t>GlobalAICommunity</a:t>
+            </a:r>
+            <a:r>
+              <a:rPr sz="2400" b="0" dirty="0">
+                <a:solidFill>
+                  <a:schemeClr val="bg1"/>
+                </a:solidFill>
+                <a:latin typeface="Carlito"/>
+              </a:rPr>
+              <a:t>/</a:t>
+            </a:r>
+            <a:r>
+              <a:rPr sz="2400" b="0" dirty="0" err="1">
+                <a:solidFill>
+                  <a:schemeClr val="bg1"/>
+                </a:solidFill>
+                <a:latin typeface="Carlito"/>
+              </a:rPr>
+              <a:t>mcp</a:t>
+            </a:r>
+            <a:r>
+              <a:rPr sz="2400" b="0" dirty="0">
+                <a:solidFill>
+                  <a:schemeClr val="bg1"/>
+                </a:solidFill>
+                <a:latin typeface="Carlito"/>
+              </a:rPr>
+              <a:t>-</a:t>
+            </a:r>
+            <a:r>
+              <a:rPr sz="2400" b="0" dirty="0" err="1">
+                <a:solidFill>
+                  <a:schemeClr val="bg1"/>
+                </a:solidFill>
+                <a:latin typeface="Carlito"/>
+              </a:rPr>
+              <a:t>fl</a:t>
+            </a:r>
+            <a:r>
+              <a:rPr sz="2400" b="0" dirty="0">
+                <a:solidFill>
+                  <a:schemeClr val="bg1"/>
+                </a:solidFill>
+                <a:latin typeface="Carlito"/>
+              </a:rPr>
+              <a:t>-workshop</a:t>
+            </a:r>
+          </a:p>
+        </p:txBody>
+      </p:sp>
+      <p:sp>
+        <p:nvSpPr>
+          <p:cNvPr id="20" name="TextBox 19"/>
+          <p:cNvSpPr txBox="1"/>
+          <p:nvPr/>
+        </p:nvSpPr>
+        <p:spPr>
+          <a:xfrm>
+            <a:off x="658368" y="6190488"/>
+            <a:ext cx="10789920" cy="228600"/>
+          </a:xfrm>
+          <a:prstGeom prst="rect">
+            <a:avLst/>
+          </a:prstGeom>
+          <a:noFill/>
+        </p:spPr>
+        <p:txBody>
+          <a:bodyPr wrap="square" lIns="0" tIns="0" rIns="0" bIns="0">
+            <a:spAutoFit/>
+          </a:bodyPr>
+          <a:lstStyle/>
+          <a:p>
+            <a:pPr>
+              <a:spcAft>
+                <a:spcPts val="900"/>
+              </a:spcAft>
+            </a:pPr>
+            <a:r>
+              <a:rPr sz="1200" b="0">
+                <a:solidFill>
+                  <a:srgbClr val="AAB7D8"/>
+                </a:solidFill>
+                <a:latin typeface="Carlito"/>
+              </a:rPr>
+              <a:t>Use the Codespaces guide for this route rather than the Windows VM commands.</a:t>
+            </a:r>
+          </a:p>
+        </p:txBody>
+      </p:sp>
+    </p:spTree>
+  </p:cSld>
+  <p:clrMapOvr>
+    <a:masterClrMapping/>
+  </p:clrMapOvr>
+</p:sld>
+</file>
+
+<file path=ppt/slides/slide8.xml><?xml version="1.0" encoding="utf-8"?>
 <p:sld xmlns:a="http://schemas.openxmlformats.org/drawingml/2006/main" xmlns:r="http://schemas.openxmlformats.org/officeDocument/2006/relationships" xmlns:p="http://schemas.openxmlformats.org/presentationml/2006/main">
   <p:cSld name="Slide 10">
     <p:spTree>
@@ -7217,8 +9123,8 @@
         </p:blipFill>
         <p:spPr>
           <a:xfrm>
-            <a:off x="6858000" y="5230368"/>
-            <a:ext cx="4892040" cy="1143000"/>
+            <a:off x="7592862" y="5230368"/>
+            <a:ext cx="3422315" cy="1143000"/>
           </a:xfrm>
           <a:prstGeom prst="rect">
             <a:avLst/>
@@ -7281,7 +9187,7 @@
 </p:sld>
 </file>
 
-<file path=ppt/slides/slide7.xml><?xml version="1.0" encoding="utf-8"?>
+<file path=ppt/slides/slide9.xml><?xml version="1.0" encoding="utf-8"?>
 <p:sld xmlns:a="http://schemas.openxmlformats.org/drawingml/2006/main" xmlns:r="http://schemas.openxmlformats.org/officeDocument/2006/relationships" xmlns:p="http://schemas.openxmlformats.org/presentationml/2006/main">
   <p:cSld name="Slide 12">
     <p:spTree>
@@ -7708,7 +9614,7 @@
               <a:buNone/>
             </a:pPr>
             <a:r>
-              <a:rPr lang="en-US" sz="2000" b="1">
+              <a:rPr lang="en-US" sz="2000" b="1" dirty="0">
                 <a:solidFill>
                   <a:srgbClr val="F8FBFF"/>
                 </a:solidFill>
@@ -7749,7 +9655,7 @@
               <a:buNone/>
             </a:pPr>
             <a:r>
-              <a:rPr lang="en-US" sz="1300">
+              <a:rPr lang="en-US" sz="1300" dirty="0">
                 <a:solidFill>
                   <a:srgbClr val="AAB7D8"/>
                 </a:solidFill>
@@ -7771,7 +9677,7 @@
         </p:nvSpPr>
         <p:spPr>
           <a:xfrm>
-            <a:off x="3063240" y="4526280"/>
+            <a:off x="3063240" y="5503435"/>
             <a:ext cx="1508760" cy="347472"/>
           </a:xfrm>
           <a:prstGeom prst="roundRect">
@@ -7807,7 +9713,7 @@
         </p:nvSpPr>
         <p:spPr>
           <a:xfrm>
-            <a:off x="3191256" y="4599432"/>
+            <a:off x="3191256" y="5576587"/>
             <a:ext cx="1252728" cy="164592"/>
           </a:xfrm>
           <a:prstGeom prst="rect">
@@ -7824,7 +9730,7 @@
               <a:buNone/>
             </a:pPr>
             <a:r>
-              <a:rPr lang="en-US" sz="850" b="1" kern="0" spc="110">
+              <a:rPr lang="en-US" sz="850" b="1" kern="0" spc="110" dirty="0">
                 <a:solidFill>
                   <a:srgbClr val="F8FBFF"/>
                 </a:solidFill>
@@ -7846,7 +9752,7 @@
         </p:nvSpPr>
         <p:spPr>
           <a:xfrm>
-            <a:off x="4800600" y="4526280"/>
+            <a:off x="4800600" y="5503435"/>
             <a:ext cx="1508760" cy="347472"/>
           </a:xfrm>
           <a:prstGeom prst="roundRect">
@@ -7882,7 +9788,7 @@
         </p:nvSpPr>
         <p:spPr>
           <a:xfrm>
-            <a:off x="4928616" y="4599432"/>
+            <a:off x="4928616" y="5576587"/>
             <a:ext cx="1252728" cy="164592"/>
           </a:xfrm>
           <a:prstGeom prst="rect">
@@ -7931,8 +9837,8 @@
         </p:blipFill>
         <p:spPr>
           <a:xfrm>
-            <a:off x="6858000" y="5230368"/>
-            <a:ext cx="4892040" cy="1143000"/>
+            <a:off x="7592862" y="5230368"/>
+            <a:ext cx="3422315" cy="1143000"/>
           </a:xfrm>
           <a:prstGeom prst="rect">
             <a:avLst/>
@@ -7984,6 +9890,96 @@
               <a:t>7</a:t>
             </a:r>
             <a:endParaRPr lang="en-US"/>
+          </a:p>
+        </p:txBody>
+      </p:sp>
+      <p:sp>
+        <p:nvSpPr>
+          <p:cNvPr id="21" name="Text 10">
+            <a:extLst>
+              <a:ext uri="{FF2B5EF4-FFF2-40B4-BE49-F238E27FC236}">
+                <a16:creationId xmlns:a16="http://schemas.microsoft.com/office/drawing/2014/main" id="{883C520C-A0AD-BFA4-7F8F-278905E103BE}"/>
+              </a:ext>
+            </a:extLst>
+          </p:cNvPr>
+          <p:cNvSpPr/>
+          <p:nvPr/>
+        </p:nvSpPr>
+        <p:spPr>
+          <a:xfrm>
+            <a:off x="3044952" y="4462451"/>
+            <a:ext cx="5943600" cy="365760"/>
+          </a:xfrm>
+          <a:prstGeom prst="rect">
+            <a:avLst/>
+          </a:prstGeom>
+          <a:noFill/>
+          <a:ln/>
+        </p:spPr>
+        <p:txBody>
+          <a:bodyPr wrap="square" lIns="0" tIns="0" rIns="0" bIns="0" rtlCol="0" anchor="ctr"/>
+          <a:lstStyle/>
+          <a:p>
+            <a:pPr marL="0" indent="0">
+              <a:buNone/>
+            </a:pPr>
+            <a:r>
+              <a:rPr lang="en-US" sz="2000" b="1" dirty="0">
+                <a:solidFill>
+                  <a:srgbClr val="F8FBFF"/>
+                </a:solidFill>
+                <a:latin typeface="Carlito" pitchFamily="34" charset="0"/>
+                <a:ea typeface="Carlito" pitchFamily="34" charset="-122"/>
+                <a:cs typeface="Carlito" pitchFamily="34" charset="-120"/>
+              </a:rPr>
+              <a:t>Microsoft Foundry Discord Community</a:t>
+            </a:r>
+            <a:endParaRPr lang="en-US" sz="2000" dirty="0"/>
+          </a:p>
+        </p:txBody>
+      </p:sp>
+      <p:sp>
+        <p:nvSpPr>
+          <p:cNvPr id="23" name="Text 11">
+            <a:hlinkClick r:id="rId5"/>
+            <a:extLst>
+              <a:ext uri="{FF2B5EF4-FFF2-40B4-BE49-F238E27FC236}">
+                <a16:creationId xmlns:a16="http://schemas.microsoft.com/office/drawing/2014/main" id="{E9F90014-9E99-B9DD-F64E-3F7C8B999C74}"/>
+              </a:ext>
+            </a:extLst>
+          </p:cNvPr>
+          <p:cNvSpPr/>
+          <p:nvPr/>
+        </p:nvSpPr>
+        <p:spPr>
+          <a:xfrm>
+            <a:off x="3044952" y="4919651"/>
+            <a:ext cx="4114800" cy="274320"/>
+          </a:xfrm>
+          <a:prstGeom prst="rect">
+            <a:avLst/>
+          </a:prstGeom>
+          <a:noFill/>
+          <a:ln/>
+        </p:spPr>
+        <p:txBody>
+          <a:bodyPr wrap="square" lIns="0" tIns="0" rIns="0" bIns="0" rtlCol="0" anchor="ctr"/>
+          <a:lstStyle/>
+          <a:p>
+            <a:pPr marL="0" indent="0">
+              <a:buNone/>
+            </a:pPr>
+            <a:r>
+              <a:rPr lang="en-US" sz="1300" dirty="0">
+                <a:solidFill>
+                  <a:srgbClr val="AAB7D8"/>
+                </a:solidFill>
+                <a:latin typeface="Carlito" pitchFamily="34" charset="0"/>
+                <a:ea typeface="Carlito" pitchFamily="34" charset="-122"/>
+              </a:rPr>
+              <a:t>aka.ms/foundry/discord</a:t>
+            </a:r>
+            <a:endParaRPr lang="en-US" sz="1300" dirty="0"/>
           </a:p>
         </p:txBody>
       </p:sp>

</xml_diff>